<commit_message>
Update presentations and ignore local files
Refresh the Roberts presentation decks and expand `.gitignore` to exclude the local `tts/` directory and macOS `.DS_Store` files from future commits.
</commit_message>
<xml_diff>
--- a/Roberts-RDA.pptx
+++ b/Roberts-RDA.pptx
@@ -3016,9 +3016,26 @@
         </p:spPr>
         <p:txBody>
           <a:bodyPr wrap="square" lIns="0" tIns="0" rIns="0" bIns="0" rtlCol="0" anchor="t">
-            <a:normAutofit/>
-          </a:bodyPr>
-          <a:lstStyle/>
+            <a:normAutofit lnSpcReduction="10000"/>
+          </a:bodyPr>
+          <a:lstStyle/>
+          <a:p>
+            <a:pPr>
+              <a:lnSpc>
+                <a:spcPct val="100000"/>
+              </a:lnSpc>
+            </a:pPr>
+            <a:r>
+              <a:rPr lang="en-US" dirty="0">
+                <a:solidFill>
+                  <a:schemeClr val="bg1">
+                    <a:lumMod val="90000"/>
+                  </a:schemeClr>
+                </a:solidFill>
+              </a:rPr>
+              <a:t>International Conference on Shellfish Restoration</a:t>
+            </a:r>
+          </a:p>
           <a:p>
             <a:pPr marL="0" indent="0" algn="l">
               <a:lnSpc>

</xml_diff>